<commit_message>
Deck: clickable demo screens and an open-live-app button
Co-Authored-By: Claude Opus 5.5 <noreply@anthropic.com>
</commit_message>
<xml_diff>
--- a/frontend/public/Vaachak-THINK-AI-4.0.pptx
+++ b/frontend/public/Vaachak-THINK-AI-4.0.pptx
@@ -4702,6 +4702,94 @@
           <a:p/>
         </p:txBody>
       </p:sp>
+      <p:sp>
+        <p:nvSpPr>
+          <p:cNvPr id="19" name="Rounded Rectangle 18">
+            <a:hlinkClick r:id="rId12"/>
+          </p:cNvPr>
+          <p:cNvSpPr/>
+          <p:nvPr/>
+        </p:nvSpPr>
+        <p:spPr>
+          <a:xfrm>
+            <a:off x="14218920" y="9006840"/>
+            <a:ext cx="3017520" cy="566928"/>
+          </a:xfrm>
+          <a:prstGeom prst="roundRect">
+            <a:avLst>
+              <a:gd name="adj" fmla="val 30000"/>
+            </a:avLst>
+          </a:prstGeom>
+          <a:solidFill>
+            <a:srgbClr val="0B2A3A"/>
+          </a:solidFill>
+          <a:ln w="15875">
+            <a:solidFill>
+              <a:srgbClr val="2EC4F1"/>
+            </a:solidFill>
+          </a:ln>
+          <a:effectLst/>
+        </p:spPr>
+        <p:style>
+          <a:lnRef idx="1">
+            <a:schemeClr val="accent1"/>
+          </a:lnRef>
+          <a:fillRef idx="3">
+            <a:schemeClr val="accent1"/>
+          </a:fillRef>
+          <a:effectRef idx="2">
+            <a:schemeClr val="accent1"/>
+          </a:effectRef>
+          <a:fontRef idx="minor">
+            <a:schemeClr val="lt1"/>
+          </a:fontRef>
+        </p:style>
+        <p:txBody>
+          <a:bodyPr rtlCol="0" anchor="ctr"/>
+          <a:lstStyle/>
+          <a:p>
+            <a:pPr algn="ctr"/>
+          </a:p>
+        </p:txBody>
+      </p:sp>
+      <p:sp>
+        <p:nvSpPr>
+          <p:cNvPr id="20" name="TextBox 19">
+            <a:hlinkClick r:id="rId12"/>
+          </p:cNvPr>
+          <p:cNvSpPr txBox="1"/>
+          <p:nvPr/>
+        </p:nvSpPr>
+        <p:spPr>
+          <a:xfrm>
+            <a:off x="14218920" y="9006840"/>
+            <a:ext cx="3017520" cy="566928"/>
+          </a:xfrm>
+          <a:prstGeom prst="rect">
+            <a:avLst/>
+          </a:prstGeom>
+          <a:noFill/>
+        </p:spPr>
+        <p:txBody>
+          <a:bodyPr wrap="square" lIns="0" rIns="0" tIns="0" bIns="0" anchor="ctr">
+            <a:spAutoFit/>
+          </a:bodyPr>
+          <a:lstStyle/>
+          <a:p>
+            <a:pPr algn="ctr"/>
+            <a:r>
+              <a:rPr sz="1400" b="1">
+                <a:solidFill>
+                  <a:srgbClr val="2EC4F1"/>
+                </a:solidFill>
+                <a:latin typeface="Segoe UI Semibold"/>
+                <a:cs typeface="Nirmala UI"/>
+              </a:rPr>
+              <a:t>▶  Open the live app</a:t>
+            </a:r>
+          </a:p>
+        </p:txBody>
+      </p:sp>
     </p:spTree>
   </p:cSld>
   <p:clrMapOvr>
@@ -8362,7 +8450,9 @@
       </p:sp>
       <p:sp>
         <p:nvSpPr>
-          <p:cNvPr id="7" name="Rounded Rectangle 6"/>
+          <p:cNvPr id="7" name="Rounded Rectangle 6">
+            <a:hlinkClick r:id="rId4"/>
+          </p:cNvPr>
           <p:cNvSpPr/>
           <p:nvPr/>
         </p:nvSpPr>
@@ -8410,7 +8500,9 @@
       </p:sp>
       <p:pic>
         <p:nvPicPr>
-          <p:cNvPr id="8" name="Picture 7" descr="scam.png"/>
+          <p:cNvPr id="8" name="Picture 7" descr="scam.png">
+            <a:hlinkClick r:id="rId4"/>
+          </p:cNvPr>
           <p:cNvPicPr>
             <a:picLocks noChangeAspect="1"/>
           </p:cNvPicPr>
@@ -8504,7 +8596,9 @@
       </p:sp>
       <p:sp>
         <p:nvSpPr>
-          <p:cNvPr id="10" name="Rounded Rectangle 9"/>
+          <p:cNvPr id="10" name="Rounded Rectangle 9">
+            <a:hlinkClick r:id="rId6"/>
+          </p:cNvPr>
           <p:cNvSpPr/>
           <p:nvPr/>
         </p:nvSpPr>
@@ -8552,14 +8646,16 @@
       </p:sp>
       <p:pic>
         <p:nvPicPr>
-          <p:cNvPr id="11" name="Picture 10" descr="bill.png"/>
+          <p:cNvPr id="11" name="Picture 10" descr="bill.png">
+            <a:hlinkClick r:id="rId6"/>
+          </p:cNvPr>
           <p:cNvPicPr>
             <a:picLocks noChangeAspect="1"/>
           </p:cNvPicPr>
           <p:nvPr/>
         </p:nvPicPr>
         <p:blipFill>
-          <a:blip r:embed="rId4"/>
+          <a:blip r:embed="rId5"/>
           <a:stretch>
             <a:fillRect/>
           </a:stretch>
@@ -8646,7 +8742,9 @@
       </p:sp>
       <p:sp>
         <p:nvSpPr>
-          <p:cNvPr id="13" name="Rounded Rectangle 12"/>
+          <p:cNvPr id="13" name="Rounded Rectangle 12">
+            <a:hlinkClick r:id="rId8"/>
+          </p:cNvPr>
           <p:cNvSpPr/>
           <p:nvPr/>
         </p:nvSpPr>
@@ -8694,14 +8792,16 @@
       </p:sp>
       <p:pic>
         <p:nvPicPr>
-          <p:cNvPr id="14" name="Picture 13" descr="rx-meds.png"/>
+          <p:cNvPr id="14" name="Picture 13" descr="rx-meds.png">
+            <a:hlinkClick r:id="rId8"/>
+          </p:cNvPr>
           <p:cNvPicPr>
             <a:picLocks noChangeAspect="1"/>
           </p:cNvPicPr>
           <p:nvPr/>
         </p:nvPicPr>
         <p:blipFill>
-          <a:blip r:embed="rId5"/>
+          <a:blip r:embed="rId7"/>
           <a:stretch>
             <a:fillRect/>
           </a:stretch>
@@ -8788,7 +8888,9 @@
       </p:sp>
       <p:sp>
         <p:nvSpPr>
-          <p:cNvPr id="16" name="Rounded Rectangle 15"/>
+          <p:cNvPr id="16" name="Rounded Rectangle 15">
+            <a:hlinkClick r:id="rId10"/>
+          </p:cNvPr>
           <p:cNvSpPr/>
           <p:nvPr/>
         </p:nvSpPr>
@@ -8836,14 +8938,16 @@
       </p:sp>
       <p:pic>
         <p:nvPicPr>
-          <p:cNvPr id="17" name="Picture 16" descr="papers.png"/>
+          <p:cNvPr id="17" name="Picture 16" descr="papers.png">
+            <a:hlinkClick r:id="rId10"/>
+          </p:cNvPr>
           <p:cNvPicPr>
             <a:picLocks noChangeAspect="1"/>
           </p:cNvPicPr>
           <p:nvPr/>
         </p:nvPicPr>
         <p:blipFill>
-          <a:blip r:embed="rId6"/>
+          <a:blip r:embed="rId9"/>
           <a:stretch>
             <a:fillRect/>
           </a:stretch>
@@ -8936,8 +9040,8 @@
         </p:nvSpPr>
         <p:spPr>
           <a:xfrm>
-            <a:off x="12115800" y="2395728"/>
-            <a:ext cx="4754880" cy="320040"/>
+            <a:off x="2194560" y="8001000"/>
+            <a:ext cx="9144000" cy="320040"/>
           </a:xfrm>
           <a:prstGeom prst="rect">
             <a:avLst/>
@@ -8952,6 +9056,42 @@
           <a:p>
             <a:pPr algn="l"/>
             <a:r>
+              <a:rPr sz="1200" b="1">
+                <a:solidFill>
+                  <a:srgbClr val="2EC4F1"/>
+                </a:solidFill>
+                <a:latin typeface="Segoe UI Semibold"/>
+                <a:cs typeface="Nirmala UI"/>
+              </a:rPr>
+              <a:t>↗  Click any screen to open that demo in the live app</a:t>
+            </a:r>
+          </a:p>
+        </p:txBody>
+      </p:sp>
+      <p:sp>
+        <p:nvSpPr>
+          <p:cNvPr id="20" name="TextBox 19"/>
+          <p:cNvSpPr txBox="1"/>
+          <p:nvPr/>
+        </p:nvSpPr>
+        <p:spPr>
+          <a:xfrm>
+            <a:off x="12115800" y="2395728"/>
+            <a:ext cx="4754880" cy="320040"/>
+          </a:xfrm>
+          <a:prstGeom prst="rect">
+            <a:avLst/>
+          </a:prstGeom>
+          <a:noFill/>
+        </p:spPr>
+        <p:txBody>
+          <a:bodyPr wrap="square" lIns="0" rIns="0" tIns="0" bIns="0" anchor="t">
+            <a:spAutoFit/>
+          </a:bodyPr>
+          <a:lstStyle/>
+          <a:p>
+            <a:pPr algn="l"/>
+            <a:r>
               <a:rPr sz="1100" b="1" spc="150">
                 <a:solidFill>
                   <a:srgbClr val="2EC4F1"/>
@@ -8966,7 +9106,7 @@
       </p:sp>
       <p:sp>
         <p:nvSpPr>
-          <p:cNvPr id="20" name="Rounded Rectangle 19"/>
+          <p:cNvPr id="21" name="Rounded Rectangle 20"/>
           <p:cNvSpPr/>
           <p:nvPr/>
         </p:nvSpPr>
@@ -9016,7 +9156,7 @@
       </p:sp>
       <p:sp>
         <p:nvSpPr>
-          <p:cNvPr id="21" name="TextBox 20"/>
+          <p:cNvPr id="22" name="TextBox 21"/>
           <p:cNvSpPr txBox="1"/>
           <p:nvPr/>
         </p:nvSpPr>
@@ -9065,7 +9205,7 @@
       </p:sp>
       <p:sp>
         <p:nvSpPr>
-          <p:cNvPr id="22" name="Rounded Rectangle 21"/>
+          <p:cNvPr id="23" name="Rounded Rectangle 22"/>
           <p:cNvSpPr/>
           <p:nvPr/>
         </p:nvSpPr>
@@ -9115,7 +9255,7 @@
       </p:sp>
       <p:sp>
         <p:nvSpPr>
-          <p:cNvPr id="23" name="TextBox 22"/>
+          <p:cNvPr id="24" name="TextBox 23"/>
           <p:cNvSpPr txBox="1"/>
           <p:nvPr/>
         </p:nvSpPr>
@@ -9164,7 +9304,7 @@
       </p:sp>
       <p:sp>
         <p:nvSpPr>
-          <p:cNvPr id="24" name="Rounded Rectangle 23"/>
+          <p:cNvPr id="25" name="Rounded Rectangle 24"/>
           <p:cNvSpPr/>
           <p:nvPr/>
         </p:nvSpPr>
@@ -9214,7 +9354,7 @@
       </p:sp>
       <p:sp>
         <p:nvSpPr>
-          <p:cNvPr id="25" name="TextBox 24"/>
+          <p:cNvPr id="26" name="TextBox 25"/>
           <p:cNvSpPr txBox="1"/>
           <p:nvPr/>
         </p:nvSpPr>
@@ -9263,7 +9403,7 @@
       </p:sp>
       <p:sp>
         <p:nvSpPr>
-          <p:cNvPr id="26" name="Rounded Rectangle 25"/>
+          <p:cNvPr id="27" name="Rounded Rectangle 26"/>
           <p:cNvSpPr/>
           <p:nvPr/>
         </p:nvSpPr>
@@ -9313,7 +9453,7 @@
       </p:sp>
       <p:sp>
         <p:nvSpPr>
-          <p:cNvPr id="27" name="TextBox 26"/>
+          <p:cNvPr id="28" name="TextBox 27"/>
           <p:cNvSpPr txBox="1"/>
           <p:nvPr/>
         </p:nvSpPr>
@@ -9362,7 +9502,7 @@
       </p:sp>
       <p:sp>
         <p:nvSpPr>
-          <p:cNvPr id="28" name="Rounded Rectangle 27"/>
+          <p:cNvPr id="29" name="Rounded Rectangle 28"/>
           <p:cNvSpPr/>
           <p:nvPr/>
         </p:nvSpPr>
@@ -9412,7 +9552,7 @@
       </p:sp>
       <p:sp>
         <p:nvSpPr>
-          <p:cNvPr id="29" name="TextBox 28"/>
+          <p:cNvPr id="30" name="TextBox 29"/>
           <p:cNvSpPr txBox="1"/>
           <p:nvPr/>
         </p:nvSpPr>
@@ -9461,7 +9601,7 @@
       </p:sp>
       <p:sp>
         <p:nvSpPr>
-          <p:cNvPr id="30" name="Rounded Rectangle 29"/>
+          <p:cNvPr id="31" name="Rounded Rectangle 30"/>
           <p:cNvSpPr/>
           <p:nvPr/>
         </p:nvSpPr>
@@ -9511,7 +9651,7 @@
       </p:sp>
       <p:sp>
         <p:nvSpPr>
-          <p:cNvPr id="31" name="TextBox 30"/>
+          <p:cNvPr id="32" name="TextBox 31"/>
           <p:cNvSpPr txBox="1"/>
           <p:nvPr/>
         </p:nvSpPr>
@@ -9560,7 +9700,7 @@
       </p:sp>
       <p:sp>
         <p:nvSpPr>
-          <p:cNvPr id="32" name="Rounded Rectangle 31"/>
+          <p:cNvPr id="33" name="Rounded Rectangle 32"/>
           <p:cNvSpPr/>
           <p:nvPr/>
         </p:nvSpPr>
@@ -9610,8 +9750,8 @@
       </p:sp>
       <p:pic>
         <p:nvPicPr>
-          <p:cNvPr id="33" name="Picture 32" descr="qr.png">
-            <a:hlinkClick r:id="rId8"/>
+          <p:cNvPr id="34" name="Picture 33" descr="qr.png">
+            <a:hlinkClick r:id="rId10"/>
           </p:cNvPr>
           <p:cNvPicPr>
             <a:picLocks noChangeAspect="1"/>
@@ -9619,7 +9759,7 @@
           <p:nvPr/>
         </p:nvPicPr>
         <p:blipFill>
-          <a:blip r:embed="rId7"/>
+          <a:blip r:embed="rId11"/>
           <a:stretch>
             <a:fillRect/>
           </a:stretch>
@@ -9636,8 +9776,8 @@
       </p:pic>
       <p:sp>
         <p:nvSpPr>
-          <p:cNvPr id="34" name="TextBox 33">
-            <a:hlinkClick r:id="rId8"/>
+          <p:cNvPr id="35" name="TextBox 34">
+            <a:hlinkClick r:id="rId10"/>
           </p:cNvPr>
           <p:cNvSpPr txBox="1"/>
           <p:nvPr/>

</xml_diff>

<commit_message>
Deck: add GitHub link
Co-Authored-By: Claude Opus 5.5 <noreply@anthropic.com>
</commit_message>
<xml_diff>
--- a/frontend/public/Vaachak-THINK-AI-4.0.pptx
+++ b/frontend/public/Vaachak-THINK-AI-4.0.pptx
@@ -15169,7 +15169,7 @@
                 <a:latin typeface="Segoe UI"/>
                 <a:cs typeface="Nirmala UI"/>
               </a:rPr>
-              <a:t>live, tested, open on any phone</a:t>
+              <a:t>live app + open source code</a:t>
             </a:r>
           </a:p>
         </p:txBody>
@@ -15182,8 +15182,8 @@
         </p:nvSpPr>
         <p:spPr>
           <a:xfrm>
-            <a:off x="7589520" y="7543800"/>
-            <a:ext cx="6949440" cy="1005840"/>
+            <a:off x="7589520" y="7388352"/>
+            <a:ext cx="6949440" cy="1325880"/>
           </a:xfrm>
           <a:prstGeom prst="roundRect">
             <a:avLst>
@@ -15221,18 +15221,42 @@
           </a:p>
         </p:txBody>
       </p:sp>
-      <p:sp>
-        <p:nvSpPr>
-          <p:cNvPr id="47" name="TextBox 46">
-            <a:hlinkClick r:id="rId10"/>
+      <p:pic>
+        <p:nvPicPr>
+          <p:cNvPr id="47" name="Picture 46" descr="globe.png"/>
+          <p:cNvPicPr>
+            <a:picLocks noChangeAspect="1"/>
+          </p:cNvPicPr>
+          <p:nvPr/>
+        </p:nvPicPr>
+        <p:blipFill>
+          <a:blip r:embed="rId10"/>
+          <a:stretch>
+            <a:fillRect/>
+          </a:stretch>
+        </p:blipFill>
+        <p:spPr>
+          <a:xfrm>
+            <a:off x="7818120" y="7534656"/>
+            <a:ext cx="384048" cy="384048"/>
+          </a:xfrm>
+          <a:prstGeom prst="rect">
+            <a:avLst/>
+          </a:prstGeom>
+        </p:spPr>
+      </p:pic>
+      <p:sp>
+        <p:nvSpPr>
+          <p:cNvPr id="48" name="TextBox 47">
+            <a:hlinkClick r:id="rId11"/>
           </p:cNvPr>
           <p:cNvSpPr txBox="1"/>
           <p:nvPr/>
         </p:nvSpPr>
         <p:spPr>
           <a:xfrm>
-            <a:off x="7818120" y="7571231"/>
-            <a:ext cx="6583680" cy="960120"/>
+            <a:off x="8321040" y="7498079"/>
+            <a:ext cx="6035040" cy="457200"/>
           </a:xfrm>
           <a:prstGeom prst="rect">
             <a:avLst/>
@@ -15247,7 +15271,7 @@
           <a:p>
             <a:pPr algn="l"/>
             <a:r>
-              <a:rPr sz="2000" b="1">
+              <a:rPr sz="1900" b="1">
                 <a:solidFill>
                   <a:srgbClr val="2EC4F1"/>
                 </a:solidFill>
@@ -15256,10 +15280,79 @@
               </a:rPr>
               <a:t>vaachak-zeta.vercel.app</a:t>
             </a:r>
-          </a:p>
+            <a:r>
+              <a:rPr sz="1150" b="0">
+                <a:solidFill>
+                  <a:srgbClr val="B8C7D6"/>
+                </a:solidFill>
+                <a:latin typeface="Segoe UI"/>
+                <a:cs typeface="Nirmala UI"/>
+              </a:rPr>
+              <a:t>   live app</a:t>
+            </a:r>
+          </a:p>
+        </p:txBody>
+      </p:sp>
+      <p:pic>
+        <p:nvPicPr>
+          <p:cNvPr id="49" name="Picture 48" descr="brand-github.png"/>
+          <p:cNvPicPr>
+            <a:picLocks noChangeAspect="1"/>
+          </p:cNvPicPr>
+          <p:nvPr/>
+        </p:nvPicPr>
+        <p:blipFill>
+          <a:blip r:embed="rId12"/>
+          <a:stretch>
+            <a:fillRect/>
+          </a:stretch>
+        </p:blipFill>
+        <p:spPr>
+          <a:xfrm>
+            <a:off x="7836408" y="8083296"/>
+            <a:ext cx="347472" cy="347472"/>
+          </a:xfrm>
+          <a:prstGeom prst="rect">
+            <a:avLst/>
+          </a:prstGeom>
+        </p:spPr>
+      </p:pic>
+      <p:sp>
+        <p:nvSpPr>
+          <p:cNvPr id="50" name="TextBox 49">
+            <a:hlinkClick r:id="rId13"/>
+          </p:cNvPr>
+          <p:cNvSpPr txBox="1"/>
+          <p:nvPr/>
+        </p:nvSpPr>
+        <p:spPr>
+          <a:xfrm>
+            <a:off x="8321040" y="8028431"/>
+            <a:ext cx="6035040" cy="457200"/>
+          </a:xfrm>
+          <a:prstGeom prst="rect">
+            <a:avLst/>
+          </a:prstGeom>
+          <a:noFill/>
+        </p:spPr>
+        <p:txBody>
+          <a:bodyPr wrap="square" lIns="0" rIns="0" tIns="0" bIns="0" anchor="ctr">
+            <a:spAutoFit/>
+          </a:bodyPr>
+          <a:lstStyle/>
           <a:p>
             <a:pPr algn="l"/>
             <a:r>
+              <a:rPr sz="1600" b="1">
+                <a:solidFill>
+                  <a:srgbClr val="FFFFFF"/>
+                </a:solidFill>
+                <a:latin typeface="Segoe UI Semibold"/>
+                <a:cs typeface="Nirmala UI"/>
+              </a:rPr>
+              <a:t>github.com/anveshchafle-cmd/vaachak</a:t>
+            </a:r>
+            <a:r>
               <a:rPr sz="1150" b="0">
                 <a:solidFill>
                   <a:srgbClr val="B8C7D6"/>
@@ -15267,14 +15360,14 @@
                 <a:latin typeface="Segoe UI"/>
                 <a:cs typeface="Nirmala UI"/>
               </a:rPr>
-              <a:t>Tap a sample (works offline) · tap ? for a spoken tour · paste a scam SMS</a:t>
-            </a:r>
-          </a:p>
-        </p:txBody>
-      </p:sp>
-      <p:sp>
-        <p:nvSpPr>
-          <p:cNvPr id="48" name="Rounded Rectangle 47"/>
+              <a:t>   code &amp; README</a:t>
+            </a:r>
+          </a:p>
+        </p:txBody>
+      </p:sp>
+      <p:sp>
+        <p:nvSpPr>
+          <p:cNvPr id="51" name="Rounded Rectangle 50"/>
           <p:cNvSpPr/>
           <p:nvPr/>
         </p:nvSpPr>
@@ -15320,8 +15413,8 @@
       </p:sp>
       <p:pic>
         <p:nvPicPr>
-          <p:cNvPr id="49" name="Picture 48" descr="qr.png">
-            <a:hlinkClick r:id="rId10"/>
+          <p:cNvPr id="52" name="Picture 51" descr="qr.png">
+            <a:hlinkClick r:id="rId11"/>
           </p:cNvPr>
           <p:cNvPicPr>
             <a:picLocks noChangeAspect="1"/>
@@ -15329,7 +15422,7 @@
           <p:nvPr/>
         </p:nvPicPr>
         <p:blipFill>
-          <a:blip r:embed="rId11"/>
+          <a:blip r:embed="rId14"/>
           <a:stretch>
             <a:fillRect/>
           </a:stretch>
@@ -16023,8 +16116,8 @@
         </p:nvSpPr>
         <p:spPr>
           <a:xfrm>
-            <a:off x="2743200" y="8275320"/>
-            <a:ext cx="12801600" cy="365760"/>
+            <a:off x="5486400" y="8247888"/>
+            <a:ext cx="7315200" cy="365760"/>
           </a:xfrm>
           <a:prstGeom prst="rect">
             <a:avLst/>
@@ -16041,12 +16134,70 @@
             <a:r>
               <a:rPr sz="1400" b="0">
                 <a:solidFill>
-                  <a:srgbClr val="7F93A8"/>
+                  <a:srgbClr val="B8C7D6"/>
                 </a:solidFill>
                 <a:latin typeface="Segoe UI"/>
                 <a:cs typeface="Nirmala UI"/>
               </a:rPr>
-              <a:t>Team Vaachak  ·  vaachak-zeta.vercel.app</a:t>
+              <a:t>Live app:  </a:t>
+            </a:r>
+            <a:r>
+              <a:rPr sz="1400" b="1">
+                <a:solidFill>
+                  <a:srgbClr val="2EC4F1"/>
+                </a:solidFill>
+                <a:latin typeface="Segoe UI Semibold"/>
+                <a:cs typeface="Nirmala UI"/>
+              </a:rPr>
+              <a:t>vaachak-zeta.vercel.app</a:t>
+            </a:r>
+          </a:p>
+        </p:txBody>
+      </p:sp>
+      <p:sp>
+        <p:nvSpPr>
+          <p:cNvPr id="19" name="TextBox 18">
+            <a:hlinkClick r:id="rId13"/>
+          </p:cNvPr>
+          <p:cNvSpPr txBox="1"/>
+          <p:nvPr/>
+        </p:nvSpPr>
+        <p:spPr>
+          <a:xfrm>
+            <a:off x="5486400" y="8659368"/>
+            <a:ext cx="7315200" cy="365760"/>
+          </a:xfrm>
+          <a:prstGeom prst="rect">
+            <a:avLst/>
+          </a:prstGeom>
+          <a:noFill/>
+        </p:spPr>
+        <p:txBody>
+          <a:bodyPr wrap="square" lIns="0" rIns="0" tIns="0" bIns="0" anchor="t">
+            <a:spAutoFit/>
+          </a:bodyPr>
+          <a:lstStyle/>
+          <a:p>
+            <a:pPr algn="ctr"/>
+            <a:r>
+              <a:rPr sz="1400" b="0">
+                <a:solidFill>
+                  <a:srgbClr val="B8C7D6"/>
+                </a:solidFill>
+                <a:latin typeface="Segoe UI"/>
+                <a:cs typeface="Nirmala UI"/>
+              </a:rPr>
+              <a:t>Code:  </a:t>
+            </a:r>
+            <a:r>
+              <a:rPr sz="1400" b="1">
+                <a:solidFill>
+                  <a:srgbClr val="FFFFFF"/>
+                </a:solidFill>
+                <a:latin typeface="Segoe UI Semibold"/>
+                <a:cs typeface="Nirmala UI"/>
+              </a:rPr>
+              <a:t>github.com/anveshchafle-cmd/vaachak</a:t>
             </a:r>
           </a:p>
         </p:txBody>

</xml_diff>